<commit_message>
Fix Slide 13 and Slide 15 in parent presentation
- Slide 13: Add Stanford Challenge Success (Dr. Denise Pope) credential
- Slide 15: Replace GitHub URL with vjra.net

Co-Authored-By: Claude Sonnet 4.6 <noreply@anthropic.com>
</commit_message>
<xml_diff>
--- a/launch-assets/presentation-2026-04-27.pptx
+++ b/launch-assets/presentation-2026-04-27.pptx
@@ -8419,6 +8419,18 @@
                 </a:solidFill>
                 <a:latin typeface="DM Sans"/>
               </a:rPr>
+              <a:t>✦  Parent volunteer — Stanford University Challenge Success programme (Dr. Denise Pope)</a:t>
+            </a:r>
+          </a:p>
+          <a:p>
+            <a:pPr algn="l"/>
+            <a:r>
+              <a:rPr sz="1250" b="0">
+                <a:solidFill>
+                  <a:srgbClr val="445544"/>
+                </a:solidFill>
+                <a:latin typeface="DM Sans"/>
+              </a:rPr>
               <a:t>✦  Has worked with children, teens, adults, and seniors across schools and community settings</a:t>
             </a:r>
           </a:p>
@@ -9784,7 +9796,7 @@
                 </a:solidFill>
                 <a:latin typeface="DM Sans"/>
               </a:rPr>
-              <a:t>🌐  vjra17.github.io/thinkroot-site</a:t>
+              <a:t>🌐  vjra.net</a:t>
             </a:r>
           </a:p>
           <a:p>

</xml_diff>